<commit_message>
chore(slides): correct timings for sampling
</commit_message>
<xml_diff>
--- a/slides/6-sampling.pptx
+++ b/slides/6-sampling.pptx
@@ -904,6 +904,60 @@
         <p:txBody>
           <a:bodyPr/>
           <a:lstStyle/>
+          <a:p>
+            <a:r>
+              <a:rPr lang="en-US" dirty="0"/>
+              <a:t>[TIMINGS]</a:t>
+            </a:r>
+          </a:p>
+          <a:p>
+            <a:endParaRPr lang="en-US" dirty="0"/>
+          </a:p>
+          <a:p>
+            <a:r>
+              <a:rPr lang="en-US" dirty="0"/>
+              <a:t>Practice: 45m</a:t>
+            </a:r>
+          </a:p>
+          <a:p>
+            <a:r>
+              <a:rPr lang="en-US" dirty="0"/>
+              <a:t>Target: 45m</a:t>
+            </a:r>
+          </a:p>
+          <a:p>
+            <a:endParaRPr lang="en-US" dirty="0"/>
+          </a:p>
+          <a:p>
+            <a:r>
+              <a:rPr lang="en-US" dirty="0"/>
+              <a:t>Start time: 14:45</a:t>
+            </a:r>
+          </a:p>
+          <a:p>
+            <a:r>
+              <a:rPr lang="en-US" dirty="0"/>
+              <a:t>[30m break @ 15:00 – 15:30]</a:t>
+            </a:r>
+          </a:p>
+          <a:p>
+            <a:r>
+              <a:rPr lang="en-US" dirty="0"/>
+              <a:t>End time: 16:00</a:t>
+            </a:r>
+          </a:p>
+          <a:p>
+            <a:endParaRPr lang="en-US" dirty="0"/>
+          </a:p>
+          <a:p>
+            <a:r>
+              <a:rPr lang="en-US" dirty="0"/>
+              <a:t>---</a:t>
+            </a:r>
+          </a:p>
+          <a:p>
+            <a:endParaRPr lang="en-US" dirty="0"/>
+          </a:p>
           <a:p>
             <a:r>
               <a:rPr lang="en-US" dirty="0"/>

</xml_diff>